<commit_message>
fix(submission): the blue slides were blank white outside LibreOffice
`<p:bg>` was hung as a sibling of `<p:cSld>` instead of as its first child. That
is schema-invalid, and the renderers disagree about what to do with it:
LibreOffice paints the fill anyway, PowerPoint and Keynote drop it silently. The
two blue slides carry white text, so in PowerPoint they were white on white — the
result slide and the team slide, blank.

Every slide had the defect; only those two showed it, because the light fill and
the template's own background are both near-white.

The reason it survived review is that the deck is verified through the PDF, and
the PDF comes out of LibreOffice — the one renderer that hides this. So the build
now asserts the placement on the saved package, where any future regression fails
the build instead of the presentation.
</commit_message>
<xml_diff>
--- a/submission/Security-Auto-ATH.pptx
+++ b/submission/Security-Auto-ATH.pptx
@@ -6159,6 +6159,14 @@
 <file path=ppt/slides/slide1.xml><?xml version="1.0" encoding="utf-8"?>
 <p:sld xmlns:a="http://schemas.openxmlformats.org/drawingml/2006/main" xmlns:p="http://schemas.openxmlformats.org/presentationml/2006/main" xmlns:r="http://schemas.openxmlformats.org/officeDocument/2006/relationships">
   <p:cSld>
+    <p:bg>
+      <p:bgPr>
+        <a:solidFill>
+          <a:srgbClr val="FAFAFC"/>
+        </a:solidFill>
+        <a:effectLst/>
+      </p:bgPr>
+    </p:bg>
     <p:spTree>
       <p:nvGrpSpPr>
         <p:cNvPr id="1" name=""/>
@@ -6386,14 +6394,6 @@
       </p:pic>
     </p:spTree>
   </p:cSld>
-  <p:bg>
-    <p:bgPr>
-      <a:solidFill>
-        <a:srgbClr val="FAFAFC"/>
-      </a:solidFill>
-      <a:effectLst/>
-    </p:bgPr>
-  </p:bg>
   <p:clrMapOvr>
     <a:masterClrMapping/>
   </p:clrMapOvr>
@@ -6403,6 +6403,14 @@
 <file path=ppt/slides/slide10.xml><?xml version="1.0" encoding="utf-8"?>
 <p:sld xmlns:a="http://schemas.openxmlformats.org/drawingml/2006/main" xmlns:p="http://schemas.openxmlformats.org/presentationml/2006/main" xmlns:r="http://schemas.openxmlformats.org/officeDocument/2006/relationships">
   <p:cSld>
+    <p:bg>
+      <p:bgPr>
+        <a:solidFill>
+          <a:srgbClr val="FAFAFC"/>
+        </a:solidFill>
+        <a:effectLst/>
+      </p:bgPr>
+    </p:bg>
     <p:spTree>
       <p:nvGrpSpPr>
         <p:cNvPr id="1" name=""/>
@@ -6861,14 +6869,6 @@
       </p:sp>
     </p:spTree>
   </p:cSld>
-  <p:bg>
-    <p:bgPr>
-      <a:solidFill>
-        <a:srgbClr val="FAFAFC"/>
-      </a:solidFill>
-      <a:effectLst/>
-    </p:bgPr>
-  </p:bg>
   <p:clrMapOvr>
     <a:masterClrMapping/>
   </p:clrMapOvr>
@@ -6878,6 +6878,14 @@
 <file path=ppt/slides/slide11.xml><?xml version="1.0" encoding="utf-8"?>
 <p:sld xmlns:a="http://schemas.openxmlformats.org/drawingml/2006/main" xmlns:p="http://schemas.openxmlformats.org/presentationml/2006/main" xmlns:r="http://schemas.openxmlformats.org/officeDocument/2006/relationships">
   <p:cSld>
+    <p:bg>
+      <p:bgPr>
+        <a:solidFill>
+          <a:srgbClr val="FAFAFC"/>
+        </a:solidFill>
+        <a:effectLst/>
+      </p:bgPr>
+    </p:bg>
     <p:spTree>
       <p:nvGrpSpPr>
         <p:cNvPr id="1" name=""/>
@@ -7764,14 +7772,6 @@
       </p:sp>
     </p:spTree>
   </p:cSld>
-  <p:bg>
-    <p:bgPr>
-      <a:solidFill>
-        <a:srgbClr val="FAFAFC"/>
-      </a:solidFill>
-      <a:effectLst/>
-    </p:bgPr>
-  </p:bg>
   <p:clrMapOvr>
     <a:masterClrMapping/>
   </p:clrMapOvr>
@@ -7781,6 +7781,14 @@
 <file path=ppt/slides/slide12.xml><?xml version="1.0" encoding="utf-8"?>
 <p:sld xmlns:a="http://schemas.openxmlformats.org/drawingml/2006/main" xmlns:p="http://schemas.openxmlformats.org/presentationml/2006/main" xmlns:r="http://schemas.openxmlformats.org/officeDocument/2006/relationships">
   <p:cSld>
+    <p:bg>
+      <p:bgPr>
+        <a:solidFill>
+          <a:srgbClr val="FAFAFC"/>
+        </a:solidFill>
+        <a:effectLst/>
+      </p:bgPr>
+    </p:bg>
     <p:spTree>
       <p:nvGrpSpPr>
         <p:cNvPr id="1" name=""/>
@@ -8774,14 +8782,6 @@
       </p:sp>
     </p:spTree>
   </p:cSld>
-  <p:bg>
-    <p:bgPr>
-      <a:solidFill>
-        <a:srgbClr val="FAFAFC"/>
-      </a:solidFill>
-      <a:effectLst/>
-    </p:bgPr>
-  </p:bg>
   <p:clrMapOvr>
     <a:masterClrMapping/>
   </p:clrMapOvr>
@@ -8791,6 +8791,14 @@
 <file path=ppt/slides/slide13.xml><?xml version="1.0" encoding="utf-8"?>
 <p:sld xmlns:a="http://schemas.openxmlformats.org/drawingml/2006/main" xmlns:p="http://schemas.openxmlformats.org/presentationml/2006/main" xmlns:r="http://schemas.openxmlformats.org/officeDocument/2006/relationships">
   <p:cSld>
+    <p:bg>
+      <p:bgPr>
+        <a:solidFill>
+          <a:srgbClr val="FAFAFC"/>
+        </a:solidFill>
+        <a:effectLst/>
+      </p:bgPr>
+    </p:bg>
     <p:spTree>
       <p:nvGrpSpPr>
         <p:cNvPr id="1" name=""/>
@@ -9546,14 +9554,6 @@
       </p:sp>
     </p:spTree>
   </p:cSld>
-  <p:bg>
-    <p:bgPr>
-      <a:solidFill>
-        <a:srgbClr val="FAFAFC"/>
-      </a:solidFill>
-      <a:effectLst/>
-    </p:bgPr>
-  </p:bg>
   <p:clrMapOvr>
     <a:masterClrMapping/>
   </p:clrMapOvr>
@@ -9563,6 +9563,14 @@
 <file path=ppt/slides/slide14.xml><?xml version="1.0" encoding="utf-8"?>
 <p:sld xmlns:a="http://schemas.openxmlformats.org/drawingml/2006/main" xmlns:p="http://schemas.openxmlformats.org/presentationml/2006/main" xmlns:r="http://schemas.openxmlformats.org/officeDocument/2006/relationships">
   <p:cSld>
+    <p:bg>
+      <p:bgPr>
+        <a:solidFill>
+          <a:srgbClr val="FAFAFC"/>
+        </a:solidFill>
+        <a:effectLst/>
+      </p:bgPr>
+    </p:bg>
     <p:spTree>
       <p:nvGrpSpPr>
         <p:cNvPr id="1" name=""/>
@@ -10347,14 +10355,6 @@
       </p:sp>
     </p:spTree>
   </p:cSld>
-  <p:bg>
-    <p:bgPr>
-      <a:solidFill>
-        <a:srgbClr val="FAFAFC"/>
-      </a:solidFill>
-      <a:effectLst/>
-    </p:bgPr>
-  </p:bg>
   <p:clrMapOvr>
     <a:masterClrMapping/>
   </p:clrMapOvr>
@@ -10364,6 +10364,14 @@
 <file path=ppt/slides/slide15.xml><?xml version="1.0" encoding="utf-8"?>
 <p:sld xmlns:a="http://schemas.openxmlformats.org/drawingml/2006/main" xmlns:p="http://schemas.openxmlformats.org/presentationml/2006/main" xmlns:r="http://schemas.openxmlformats.org/officeDocument/2006/relationships">
   <p:cSld>
+    <p:bg>
+      <p:bgPr>
+        <a:solidFill>
+          <a:srgbClr val="FAFAFC"/>
+        </a:solidFill>
+        <a:effectLst/>
+      </p:bgPr>
+    </p:bg>
     <p:spTree>
       <p:nvGrpSpPr>
         <p:cNvPr id="1" name=""/>
@@ -11123,14 +11131,6 @@
       </p:sp>
     </p:spTree>
   </p:cSld>
-  <p:bg>
-    <p:bgPr>
-      <a:solidFill>
-        <a:srgbClr val="FAFAFC"/>
-      </a:solidFill>
-      <a:effectLst/>
-    </p:bgPr>
-  </p:bg>
   <p:clrMapOvr>
     <a:masterClrMapping/>
   </p:clrMapOvr>
@@ -11140,6 +11140,14 @@
 <file path=ppt/slides/slide16.xml><?xml version="1.0" encoding="utf-8"?>
 <p:sld xmlns:a="http://schemas.openxmlformats.org/drawingml/2006/main" xmlns:p="http://schemas.openxmlformats.org/presentationml/2006/main" xmlns:r="http://schemas.openxmlformats.org/officeDocument/2006/relationships">
   <p:cSld>
+    <p:bg>
+      <p:bgPr>
+        <a:solidFill>
+          <a:srgbClr val="FAFAFC"/>
+        </a:solidFill>
+        <a:effectLst/>
+      </p:bgPr>
+    </p:bg>
     <p:spTree>
       <p:nvGrpSpPr>
         <p:cNvPr id="1" name=""/>
@@ -11356,14 +11364,6 @@
       </p:sp>
     </p:spTree>
   </p:cSld>
-  <p:bg>
-    <p:bgPr>
-      <a:solidFill>
-        <a:srgbClr val="FAFAFC"/>
-      </a:solidFill>
-      <a:effectLst/>
-    </p:bgPr>
-  </p:bg>
   <p:clrMapOvr>
     <a:masterClrMapping/>
   </p:clrMapOvr>
@@ -11373,6 +11373,14 @@
 <file path=ppt/slides/slide17.xml><?xml version="1.0" encoding="utf-8"?>
 <p:sld xmlns:a="http://schemas.openxmlformats.org/drawingml/2006/main" xmlns:p="http://schemas.openxmlformats.org/presentationml/2006/main" xmlns:r="http://schemas.openxmlformats.org/officeDocument/2006/relationships">
   <p:cSld>
+    <p:bg>
+      <p:bgPr>
+        <a:solidFill>
+          <a:srgbClr val="FAFAFC"/>
+        </a:solidFill>
+        <a:effectLst/>
+      </p:bgPr>
+    </p:bg>
     <p:spTree>
       <p:nvGrpSpPr>
         <p:cNvPr id="1" name=""/>
@@ -11691,14 +11699,6 @@
       </p:sp>
     </p:spTree>
   </p:cSld>
-  <p:bg>
-    <p:bgPr>
-      <a:solidFill>
-        <a:srgbClr val="FAFAFC"/>
-      </a:solidFill>
-      <a:effectLst/>
-    </p:bgPr>
-  </p:bg>
   <p:clrMapOvr>
     <a:masterClrMapping/>
   </p:clrMapOvr>
@@ -11708,6 +11708,14 @@
 <file path=ppt/slides/slide18.xml><?xml version="1.0" encoding="utf-8"?>
 <p:sld xmlns:a="http://schemas.openxmlformats.org/drawingml/2006/main" xmlns:p="http://schemas.openxmlformats.org/presentationml/2006/main" xmlns:r="http://schemas.openxmlformats.org/officeDocument/2006/relationships">
   <p:cSld>
+    <p:bg>
+      <p:bgPr>
+        <a:solidFill>
+          <a:srgbClr val="FAFAFC"/>
+        </a:solidFill>
+        <a:effectLst/>
+      </p:bgPr>
+    </p:bg>
     <p:spTree>
       <p:nvGrpSpPr>
         <p:cNvPr id="1" name=""/>
@@ -12026,14 +12034,6 @@
       </p:sp>
     </p:spTree>
   </p:cSld>
-  <p:bg>
-    <p:bgPr>
-      <a:solidFill>
-        <a:srgbClr val="FAFAFC"/>
-      </a:solidFill>
-      <a:effectLst/>
-    </p:bgPr>
-  </p:bg>
   <p:clrMapOvr>
     <a:masterClrMapping/>
   </p:clrMapOvr>
@@ -12043,6 +12043,14 @@
 <file path=ppt/slides/slide19.xml><?xml version="1.0" encoding="utf-8"?>
 <p:sld xmlns:a="http://schemas.openxmlformats.org/drawingml/2006/main" xmlns:p="http://schemas.openxmlformats.org/presentationml/2006/main" xmlns:r="http://schemas.openxmlformats.org/officeDocument/2006/relationships">
   <p:cSld>
+    <p:bg>
+      <p:bgPr>
+        <a:solidFill>
+          <a:srgbClr val="FAFAFC"/>
+        </a:solidFill>
+        <a:effectLst/>
+      </p:bgPr>
+    </p:bg>
     <p:spTree>
       <p:nvGrpSpPr>
         <p:cNvPr id="1" name=""/>
@@ -13210,14 +13218,6 @@
       </p:sp>
     </p:spTree>
   </p:cSld>
-  <p:bg>
-    <p:bgPr>
-      <a:solidFill>
-        <a:srgbClr val="FAFAFC"/>
-      </a:solidFill>
-      <a:effectLst/>
-    </p:bgPr>
-  </p:bg>
   <p:clrMapOvr>
     <a:masterClrMapping/>
   </p:clrMapOvr>
@@ -13227,6 +13227,14 @@
 <file path=ppt/slides/slide2.xml><?xml version="1.0" encoding="utf-8"?>
 <p:sld xmlns:a="http://schemas.openxmlformats.org/drawingml/2006/main" xmlns:p="http://schemas.openxmlformats.org/presentationml/2006/main" xmlns:r="http://schemas.openxmlformats.org/officeDocument/2006/relationships">
   <p:cSld>
+    <p:bg>
+      <p:bgPr>
+        <a:solidFill>
+          <a:srgbClr val="FAFAFC"/>
+        </a:solidFill>
+        <a:effectLst/>
+      </p:bgPr>
+    </p:bg>
     <p:spTree>
       <p:nvGrpSpPr>
         <p:cNvPr id="1" name=""/>
@@ -13546,14 +13554,6 @@
       </p:sp>
     </p:spTree>
   </p:cSld>
-  <p:bg>
-    <p:bgPr>
-      <a:solidFill>
-        <a:srgbClr val="FAFAFC"/>
-      </a:solidFill>
-      <a:effectLst/>
-    </p:bgPr>
-  </p:bg>
   <p:clrMapOvr>
     <a:masterClrMapping/>
   </p:clrMapOvr>
@@ -13563,6 +13563,14 @@
 <file path=ppt/slides/slide20.xml><?xml version="1.0" encoding="utf-8"?>
 <p:sld xmlns:a="http://schemas.openxmlformats.org/drawingml/2006/main" xmlns:p="http://schemas.openxmlformats.org/presentationml/2006/main" xmlns:r="http://schemas.openxmlformats.org/officeDocument/2006/relationships">
   <p:cSld>
+    <p:bg>
+      <p:bgPr>
+        <a:solidFill>
+          <a:srgbClr val="FAFAFC"/>
+        </a:solidFill>
+        <a:effectLst/>
+      </p:bgPr>
+    </p:bg>
     <p:spTree>
       <p:nvGrpSpPr>
         <p:cNvPr id="1" name=""/>
@@ -15495,14 +15503,6 @@
       </p:sp>
     </p:spTree>
   </p:cSld>
-  <p:bg>
-    <p:bgPr>
-      <a:solidFill>
-        <a:srgbClr val="FAFAFC"/>
-      </a:solidFill>
-      <a:effectLst/>
-    </p:bgPr>
-  </p:bg>
   <p:clrMapOvr>
     <a:masterClrMapping/>
   </p:clrMapOvr>
@@ -15512,6 +15512,14 @@
 <file path=ppt/slides/slide21.xml><?xml version="1.0" encoding="utf-8"?>
 <p:sld xmlns:a="http://schemas.openxmlformats.org/drawingml/2006/main" xmlns:p="http://schemas.openxmlformats.org/presentationml/2006/main" xmlns:r="http://schemas.openxmlformats.org/officeDocument/2006/relationships">
   <p:cSld>
+    <p:bg>
+      <p:bgPr>
+        <a:solidFill>
+          <a:srgbClr val="FAFAFC"/>
+        </a:solidFill>
+        <a:effectLst/>
+      </p:bgPr>
+    </p:bg>
     <p:spTree>
       <p:nvGrpSpPr>
         <p:cNvPr id="1" name=""/>
@@ -15955,14 +15963,6 @@
       </p:sp>
     </p:spTree>
   </p:cSld>
-  <p:bg>
-    <p:bgPr>
-      <a:solidFill>
-        <a:srgbClr val="FAFAFC"/>
-      </a:solidFill>
-      <a:effectLst/>
-    </p:bgPr>
-  </p:bg>
   <p:clrMapOvr>
     <a:masterClrMapping/>
   </p:clrMapOvr>
@@ -15972,6 +15972,14 @@
 <file path=ppt/slides/slide3.xml><?xml version="1.0" encoding="utf-8"?>
 <p:sld xmlns:a="http://schemas.openxmlformats.org/drawingml/2006/main" xmlns:p="http://schemas.openxmlformats.org/presentationml/2006/main" xmlns:r="http://schemas.openxmlformats.org/officeDocument/2006/relationships">
   <p:cSld>
+    <p:bg>
+      <p:bgPr>
+        <a:solidFill>
+          <a:srgbClr val="FAFAFC"/>
+        </a:solidFill>
+        <a:effectLst/>
+      </p:bgPr>
+    </p:bg>
     <p:spTree>
       <p:nvGrpSpPr>
         <p:cNvPr id="1" name=""/>
@@ -16210,14 +16218,6 @@
       </p:sp>
     </p:spTree>
   </p:cSld>
-  <p:bg>
-    <p:bgPr>
-      <a:solidFill>
-        <a:srgbClr val="FAFAFC"/>
-      </a:solidFill>
-      <a:effectLst/>
-    </p:bgPr>
-  </p:bg>
   <p:clrMapOvr>
     <a:masterClrMapping/>
   </p:clrMapOvr>
@@ -16227,6 +16227,14 @@
 <file path=ppt/slides/slide4.xml><?xml version="1.0" encoding="utf-8"?>
 <p:sld xmlns:a="http://schemas.openxmlformats.org/drawingml/2006/main" xmlns:p="http://schemas.openxmlformats.org/presentationml/2006/main" xmlns:r="http://schemas.openxmlformats.org/officeDocument/2006/relationships">
   <p:cSld>
+    <p:bg>
+      <p:bgPr>
+        <a:solidFill>
+          <a:srgbClr val="FAFAFC"/>
+        </a:solidFill>
+        <a:effectLst/>
+      </p:bgPr>
+    </p:bg>
     <p:spTree>
       <p:nvGrpSpPr>
         <p:cNvPr id="1" name=""/>
@@ -16726,14 +16734,6 @@
       </p:sp>
     </p:spTree>
   </p:cSld>
-  <p:bg>
-    <p:bgPr>
-      <a:solidFill>
-        <a:srgbClr val="FAFAFC"/>
-      </a:solidFill>
-      <a:effectLst/>
-    </p:bgPr>
-  </p:bg>
   <p:clrMapOvr>
     <a:masterClrMapping/>
   </p:clrMapOvr>
@@ -16743,6 +16743,14 @@
 <file path=ppt/slides/slide5.xml><?xml version="1.0" encoding="utf-8"?>
 <p:sld xmlns:a="http://schemas.openxmlformats.org/drawingml/2006/main" xmlns:p="http://schemas.openxmlformats.org/presentationml/2006/main" xmlns:r="http://schemas.openxmlformats.org/officeDocument/2006/relationships">
   <p:cSld>
+    <p:bg>
+      <p:bgPr>
+        <a:solidFill>
+          <a:srgbClr val="FAFAFC"/>
+        </a:solidFill>
+        <a:effectLst/>
+      </p:bgPr>
+    </p:bg>
     <p:spTree>
       <p:nvGrpSpPr>
         <p:cNvPr id="1" name=""/>
@@ -17424,14 +17432,6 @@
       </p:sp>
     </p:spTree>
   </p:cSld>
-  <p:bg>
-    <p:bgPr>
-      <a:solidFill>
-        <a:srgbClr val="FAFAFC"/>
-      </a:solidFill>
-      <a:effectLst/>
-    </p:bgPr>
-  </p:bg>
   <p:clrMapOvr>
     <a:masterClrMapping/>
   </p:clrMapOvr>
@@ -17441,6 +17441,14 @@
 <file path=ppt/slides/slide6.xml><?xml version="1.0" encoding="utf-8"?>
 <p:sld xmlns:a="http://schemas.openxmlformats.org/drawingml/2006/main" xmlns:p="http://schemas.openxmlformats.org/presentationml/2006/main" xmlns:r="http://schemas.openxmlformats.org/officeDocument/2006/relationships">
   <p:cSld>
+    <p:bg>
+      <p:bgPr>
+        <a:solidFill>
+          <a:srgbClr val="0000FF"/>
+        </a:solidFill>
+        <a:effectLst/>
+      </p:bgPr>
+    </p:bg>
     <p:spTree>
       <p:nvGrpSpPr>
         <p:cNvPr id="1" name=""/>
@@ -17918,14 +17926,6 @@
       </p:sp>
     </p:spTree>
   </p:cSld>
-  <p:bg>
-    <p:bgPr>
-      <a:solidFill>
-        <a:srgbClr val="0000FF"/>
-      </a:solidFill>
-      <a:effectLst/>
-    </p:bgPr>
-  </p:bg>
   <p:clrMapOvr>
     <a:masterClrMapping/>
   </p:clrMapOvr>
@@ -17935,6 +17935,14 @@
 <file path=ppt/slides/slide7.xml><?xml version="1.0" encoding="utf-8"?>
 <p:sld xmlns:a="http://schemas.openxmlformats.org/drawingml/2006/main" xmlns:p="http://schemas.openxmlformats.org/presentationml/2006/main" xmlns:r="http://schemas.openxmlformats.org/officeDocument/2006/relationships">
   <p:cSld>
+    <p:bg>
+      <p:bgPr>
+        <a:solidFill>
+          <a:srgbClr val="FAFAFC"/>
+        </a:solidFill>
+        <a:effectLst/>
+      </p:bgPr>
+    </p:bg>
     <p:spTree>
       <p:nvGrpSpPr>
         <p:cNvPr id="1" name=""/>
@@ -18338,14 +18346,6 @@
       </p:sp>
     </p:spTree>
   </p:cSld>
-  <p:bg>
-    <p:bgPr>
-      <a:solidFill>
-        <a:srgbClr val="FAFAFC"/>
-      </a:solidFill>
-      <a:effectLst/>
-    </p:bgPr>
-  </p:bg>
   <p:clrMapOvr>
     <a:masterClrMapping/>
   </p:clrMapOvr>
@@ -18355,6 +18355,14 @@
 <file path=ppt/slides/slide8.xml><?xml version="1.0" encoding="utf-8"?>
 <p:sld xmlns:a="http://schemas.openxmlformats.org/drawingml/2006/main" xmlns:p="http://schemas.openxmlformats.org/presentationml/2006/main" xmlns:r="http://schemas.openxmlformats.org/officeDocument/2006/relationships">
   <p:cSld>
+    <p:bg>
+      <p:bgPr>
+        <a:solidFill>
+          <a:srgbClr val="0000FF"/>
+        </a:solidFill>
+        <a:effectLst/>
+      </p:bgPr>
+    </p:bg>
     <p:spTree>
       <p:nvGrpSpPr>
         <p:cNvPr id="1" name=""/>
@@ -19280,14 +19288,6 @@
       </p:pic>
     </p:spTree>
   </p:cSld>
-  <p:bg>
-    <p:bgPr>
-      <a:solidFill>
-        <a:srgbClr val="0000FF"/>
-      </a:solidFill>
-      <a:effectLst/>
-    </p:bgPr>
-  </p:bg>
   <p:clrMapOvr>
     <a:masterClrMapping/>
   </p:clrMapOvr>
@@ -19297,6 +19297,14 @@
 <file path=ppt/slides/slide9.xml><?xml version="1.0" encoding="utf-8"?>
 <p:sld xmlns:a="http://schemas.openxmlformats.org/drawingml/2006/main" xmlns:p="http://schemas.openxmlformats.org/presentationml/2006/main" xmlns:r="http://schemas.openxmlformats.org/officeDocument/2006/relationships">
   <p:cSld>
+    <p:bg>
+      <p:bgPr>
+        <a:solidFill>
+          <a:srgbClr val="FAFAFC"/>
+        </a:solidFill>
+        <a:effectLst/>
+      </p:bgPr>
+    </p:bg>
     <p:spTree>
       <p:nvGrpSpPr>
         <p:cNvPr id="1" name=""/>
@@ -19496,14 +19504,6 @@
       </p:sp>
     </p:spTree>
   </p:cSld>
-  <p:bg>
-    <p:bgPr>
-      <a:solidFill>
-        <a:srgbClr val="FAFAFC"/>
-      </a:solidFill>
-      <a:effectLst/>
-    </p:bgPr>
-  </p:bg>
   <p:clrMapOvr>
     <a:masterClrMapping/>
   </p:clrMapOvr>

</xml_diff>